<commit_message>
fix: loai bo tu tieng Anh mo ngoac, dinh dang chuan cong thuc toan OMML va khac phuc triet de loi chu bi dinh
</commit_message>
<xml_diff>
--- a/docs/Slide_Bao_Ve_Du_An_House_Prediction.pptx
+++ b/docs/Slide_Bao_Ve_Du_An_House_Prediction.pptx
@@ -3255,7 +3255,7 @@
               </a:defRPr>
             </a:pPr>
             <a:r>
-              <a:t>NGHIÊN CỨU XÂY DỰNG HỆ THỐNG LAKEHOUSE ĐA TẦNG (MEDALLION ARCHITECTURE) TÍCH HỢP DỮ LIỆU LỚN VÀ ĐỊNH GIÁ BẤT ĐỘNG SẢN VIỆT NAM BẰNG MÔ HÌNH HỌC MÁY LIGHTGBM</a:t>
+              <a:t>NGHIÊN CỨU XÂY DỰNG HỆ THỐNG HỒ DỮ LIỆU ĐA TẦNG MEDALLION TÍCH HỢP DỮ LIỆU LỚN VÀ ĐỊNH GIÁ BẤT ĐỘNG SẢN VIỆT NAM BẰNG MÔ HÌNH HỌC MÁY LIGHTGBM</a:t>
             </a:r>
           </a:p>
           <a:p>
@@ -3271,7 +3271,7 @@
               </a:defRPr>
             </a:pPr>
             <a:r>
-              <a:t>Sinh viên thực hiện: PHẠM VĂN MINH       |       Mã sinh viên (MSV): 23010350</a:t>
+              <a:t>Sinh viên thực hiện: PHẠM VĂN MINH       |       Mã sinh viên: 23010350</a:t>
             </a:r>
           </a:p>
           <a:p>
@@ -3370,7 +3370,7 @@
               </a:defRPr>
             </a:pPr>
             <a:r>
-              <a:t>9. Thuật Toán Học Máy: Ridge Baseline vs LightGBM</a:t>
+              <a:t>9. Thuật Toán Học Máy: Hồi Quy Ridge Cơ Sở vs LightGBM</a:t>
             </a:r>
           </a:p>
         </p:txBody>
@@ -3406,7 +3406,7 @@
               </a:defRPr>
             </a:pPr>
             <a:r>
-              <a:t>SV: Phạm Văn Minh (MSV: 23010350) — Trường Công nghệ Thông tin, Đại học Phenikaa                                                     Slide 10 / 16</a:t>
+              <a:t>Sinh viên: Phạm Văn Minh - Mã sinh viên: 23010350 - Trường Đại học Phenikaa                                                     Slide 10 / 16</a:t>
             </a:r>
           </a:p>
         </p:txBody>
@@ -3450,7 +3450,7 @@
                         </a:defRPr>
                       </a:pPr>
                       <a:r>
-                        <a:t>Chỉ Số Đánh Giá (Metric)</a:t>
+                        <a:t>Chỉ Số Đánh Giá</a:t>
                       </a:r>
                     </a:p>
                   </a:txBody>
@@ -3474,7 +3474,7 @@
                         </a:defRPr>
                       </a:pPr>
                       <a:r>
-                        <a:t>Ridge Baseline</a:t>
+                        <a:t>Hồi Quy Ridge Cơ Sở</a:t>
                       </a:r>
                     </a:p>
                   </a:txBody>
@@ -3498,7 +3498,7 @@
                         </a:defRPr>
                       </a:pPr>
                       <a:r>
-                        <a:t>LightGBM Regressor</a:t>
+                        <a:t>Mô Hình LightGBM</a:t>
                       </a:r>
                     </a:p>
                   </a:txBody>
@@ -3548,7 +3548,7 @@
                         </a:defRPr>
                       </a:pPr>
                       <a:r>
-                        <a:t>Hệ số xác định R² (log-scale)</a:t>
+                        <a:t>Hệ số xác định R² trên thang logarit</a:t>
                       </a:r>
                     </a:p>
                   </a:txBody>
@@ -3646,7 +3646,7 @@
                         </a:defRPr>
                       </a:pPr>
                       <a:r>
-                        <a:t>Sai số căn quân phương RMSE (log)</a:t>
+                        <a:t>Sai số căn quân phương RMSE trên thang logarit</a:t>
                       </a:r>
                     </a:p>
                   </a:txBody>
@@ -3744,7 +3744,7 @@
                         </a:defRPr>
                       </a:pPr>
                       <a:r>
-                        <a:t>Sai số tuyệt đối trung bình MAE (log)</a:t>
+                        <a:t>Sai số tuyệt đối trung bình MAE trên thang logarit</a:t>
                       </a:r>
                     </a:p>
                   </a:txBody>
@@ -3940,7 +3940,7 @@
                         </a:defRPr>
                       </a:pPr>
                       <a:r>
-                        <a:t>Sai số tuyệt đối trung vị (MedAE)</a:t>
+                        <a:t>Sai số tuyệt đối trung vị MedAE</a:t>
                       </a:r>
                     </a:p>
                   </a:txBody>
@@ -4038,7 +4038,7 @@
                         </a:defRPr>
                       </a:pPr>
                       <a:r>
-                        <a:t>Sai số tỷ lệ trung vị (MdAPE)</a:t>
+                        <a:t>Sai số phần trăm tuyệt đối trung vị MdAPE</a:t>
                       </a:r>
                     </a:p>
                   </a:txBody>
@@ -4226,7 +4226,7 @@
               </a:defRPr>
             </a:pPr>
             <a:r>
-              <a:t>SV: Phạm Văn Minh (MSV: 23010350) — Trường Công nghệ Thông tin, Đại học Phenikaa                                                     Slide 11 / 16</a:t>
+              <a:t>Sinh viên: Phạm Văn Minh - Mã sinh viên: 23010350 - Trường Đại học Phenikaa                                                     Slide 11 / 16</a:t>
             </a:r>
           </a:p>
         </p:txBody>
@@ -4380,7 +4380,7 @@
               </a:defRPr>
             </a:pPr>
             <a:r>
-              <a:t>SV: Phạm Văn Minh (MSV: 23010350) — Trường Công nghệ Thông tin, Đại học Phenikaa                                                     Slide 12 / 16</a:t>
+              <a:t>Sinh viên: Phạm Văn Minh - Mã sinh viên: 23010350 - Trường Đại học Phenikaa                                                     Slide 12 / 16</a:t>
             </a:r>
           </a:p>
         </p:txBody>
@@ -4537,7 +4537,7 @@
                 </a:solidFill>
                 <a:latin typeface="Arial"/>
               </a:rPr>
-              <a:t>Giảm từ 217 MB (CSV thô) xuống 153.9 MB (Bronze) và 128.2 MB (Gold) - Tiết kiệm 29.1% dung lượng.</a:t>
+              <a:t>Giảm từ 217 MB tệp thô chưa nén xuống 153.9 MB Tầng Đồng và 128.2 MB Tầng Vàng - Tiết kiệm 29.1% dung lượng.</a:t>
             </a:r>
           </a:p>
           <a:p>
@@ -4632,7 +4632,7 @@
               </a:defRPr>
             </a:pPr>
             <a:r>
-              <a:t>12. Tự Động Hóa Kiểm Thử &amp; Hướng Dẫn Vận Hành 1-Click</a:t>
+              <a:t>12. Tự Động Hóa Kiểm Thử &amp; Hướng Dẫn Vận Hành Dễ Dàng</a:t>
             </a:r>
           </a:p>
         </p:txBody>
@@ -4668,7 +4668,7 @@
               </a:defRPr>
             </a:pPr>
             <a:r>
-              <a:t>SV: Phạm Văn Minh (MSV: 23010350) — Trường Công nghệ Thông tin, Đại học Phenikaa                                                     Slide 13 / 16</a:t>
+              <a:t>Sinh viên: Phạm Văn Minh - Mã sinh viên: 23010350 - Trường Đại học Phenikaa                                                     Slide 13 / 16</a:t>
             </a:r>
           </a:p>
         </p:txBody>
@@ -4718,7 +4718,7 @@
               <a:spcAft>
                 <a:spcPts val="1000"/>
               </a:spcAft>
-              <a:defRPr sz="1250" b="1">
+              <a:defRPr sz="1200" b="1">
                 <a:solidFill>
                   <a:srgbClr val="16A34A"/>
                 </a:solidFill>
@@ -4726,7 +4726,7 @@
               </a:defRPr>
             </a:pPr>
             <a:r>
-              <a:t>BỘ KIỂM THỬ TỰ ĐỘNG (10/10 TESTS PASS):</a:t>
+              <a:t>BỘ KIỂM THỬ TỰ ĐỘNG (10/10 BÀI KIỂM THỬ ĐẠT YÊU CẦU):</a:t>
             </a:r>
           </a:p>
           <a:p>
@@ -4742,7 +4742,7 @@
               </a:defRPr>
             </a:pPr>
             <a:r>
-              <a:t>✔ 1. test_directories_exist (Cấu trúc thư mục chuẩn)</a:t>
+              <a:t>✔ 1. test_directories_exist (Kiểm tra cấu trúc thư mục chuẩn)</a:t>
             </a:r>
           </a:p>
           <a:p>
@@ -4758,7 +4758,7 @@
               </a:defRPr>
             </a:pPr>
             <a:r>
-              <a:t>✔ 2. test_bronze_parquet (350,075 dòng, 3 cột Lineage)</a:t>
+              <a:t>✔ 2. test_bronze_parquet (350,075 dòng, 3 cột kiểm toán)</a:t>
             </a:r>
           </a:p>
           <a:p>
@@ -4774,7 +4774,7 @@
               </a:defRPr>
             </a:pPr>
             <a:r>
-              <a:t>✔ 3. test_silver_parquet (307,457 dòng, sạch null/âm)</a:t>
+              <a:t>✔ 3. test_silver_parquet (307,457 dòng, sạch null và âm)</a:t>
             </a:r>
           </a:p>
           <a:p>
@@ -4790,7 +4790,7 @@
               </a:defRPr>
             </a:pPr>
             <a:r>
-              <a:t>✔ 4. test_gold_parquet (300,295 dòng, cờ NLP &amp; log)</a:t>
+              <a:t>✔ 4. test_gold_parquet (300,295 dòng, cờ đặc trưng và log)</a:t>
             </a:r>
           </a:p>
           <a:p>
@@ -4806,7 +4806,7 @@
               </a:defRPr>
             </a:pPr>
             <a:r>
-              <a:t>✔ 5. test_data_quality_report (Kiểm toán JSON &amp; phễu)</a:t>
+              <a:t>✔ 5. test_data_quality_report (Kiểm toán báo cáo chất lượng)</a:t>
             </a:r>
           </a:p>
           <a:p>
@@ -4822,7 +4822,7 @@
               </a:defRPr>
             </a:pPr>
             <a:r>
-              <a:t>✔ 6. test_storage_database (Khớp 100%, 4 B-Tree Index)</a:t>
+              <a:t>✔ 6. test_storage_database (Khớp 100%, 4 chỉ mục B-Tree)</a:t>
             </a:r>
           </a:p>
           <a:p>
@@ -4838,7 +4838,7 @@
               </a:defRPr>
             </a:pPr>
             <a:r>
-              <a:t>✔ 7. test_three_way_split_protocol (70/15/15, R² &gt;= 0.80)</a:t>
+              <a:t>✔ 7. test_three_way_split_protocol (Tỷ lệ 70/15/15, R² &gt;= 0.80)</a:t>
             </a:r>
           </a:p>
           <a:p>
@@ -4854,7 +4854,7 @@
               </a:defRPr>
             </a:pPr>
             <a:r>
-              <a:t>✔ 8. test_train_serving_consistency (Đồng nhất pipeline)</a:t>
+              <a:t>✔ 8. test_train_serving_consistency (Đồng nhất quy trình)</a:t>
             </a:r>
           </a:p>
           <a:p>
@@ -4870,7 +4870,7 @@
               </a:defRPr>
             </a:pPr>
             <a:r>
-              <a:t>✔ 9. test_evaluation_diagnostics (Biểu đồ chẩn đoán)</a:t>
+              <a:t>✔ 9. test_evaluation_diagnostics (Biểu đồ chẩn đoán mô hình)</a:t>
             </a:r>
           </a:p>
           <a:p>
@@ -4886,7 +4886,7 @@
               </a:defRPr>
             </a:pPr>
             <a:r>
-              <a:t>✔ 10. test_pipeline_summary_metrics (7 mục &amp; 7 biểu đồ)</a:t>
+              <a:t>✔ 10. test_pipeline_summary_metrics (7 mục số liệu và 7 biểu đồ)</a:t>
             </a:r>
           </a:p>
         </p:txBody>
@@ -5150,7 +5150,7 @@
               </a:defRPr>
             </a:pPr>
             <a:r>
-              <a:t>SV: Phạm Văn Minh (MSV: 23010350) — Trường Công nghệ Thông tin, Đại học Phenikaa                                                     Slide 14 / 16</a:t>
+              <a:t>Sinh viên: Phạm Văn Minh - Mã sinh viên: 23010350 - Trường Đại học Phenikaa                                                     Slide 14 / 16</a:t>
             </a:r>
           </a:p>
         </p:txBody>
@@ -5208,7 +5208,7 @@
               </a:defRPr>
             </a:pPr>
             <a:r>
-              <a:t>TAB 1: KIẾN TRÚC LAKEHOUSE</a:t>
+              <a:t>TAB 1: KIẾN TRÚC HỒ DỮ LIỆU</a:t>
             </a:r>
           </a:p>
           <a:p>
@@ -5221,7 +5221,7 @@
               </a:defRPr>
             </a:pPr>
             <a:r>
-              <a:t>Trực quan hóa sơ đồ 6 tầng, quy mô 3.5M dòng trên 10 shards, lưu lượng và các thuộc tính qua từng tầng.</a:t>
+              <a:t>Trực quan hóa sơ đồ 6 tầng, quy mô 3.5 triệu dòng trên 10 phân mảnh, lưu lượng và các thuộc tính qua từng tầng.</a:t>
             </a:r>
           </a:p>
         </p:txBody>
@@ -5292,7 +5292,7 @@
               </a:defRPr>
             </a:pPr>
             <a:r>
-              <a:t>Biểu đồ phễu lưu lượng 2 panel, tỷ lệ khuyết thiếu phân 3 nhóm màu, bảng 5 số thống kê TRƯỚC vs SAU lọc ngoại lệ.</a:t>
+              <a:t>Biểu đồ phễu lưu lượng 2 panel, tỷ lệ khuyết thiếu phân 3 nhóm màu, bảng 5 số thống kê TRƯỚC và SAU khi lọc ngoại lệ.</a:t>
             </a:r>
           </a:p>
         </p:txBody>
@@ -5350,7 +5350,7 @@
               </a:defRPr>
             </a:pPr>
             <a:r>
-              <a:t>TAB 3: PHÂN TÍCH THỊ TRƯỜNG (EDA)</a:t>
+              <a:t>TAB 3: PHÂN TÍCH THỊ TRƯỜNG</a:t>
             </a:r>
           </a:p>
           <a:p>
@@ -5421,7 +5421,7 @@
               </a:defRPr>
             </a:pPr>
             <a:r>
-              <a:t>TAB 4: HIỆU NĂNG &amp; ĐỊNH GIÁ AI</a:t>
+              <a:t>TAB 4: HIỆU NĂNG &amp; ĐỊNH GIÁ</a:t>
             </a:r>
           </a:p>
           <a:p>
@@ -5434,7 +5434,7 @@
               </a:defRPr>
             </a:pPr>
             <a:r>
-              <a:t>Dashboard giám sát pipeline, hiệu quả nén Parquet Snappy, biểu mẫu định giá nhà tự động bằng LightGBM theo thời gian thực.</a:t>
+              <a:t>Bảng điều khiển giám sát quy trình, hiệu quả nén Parquet Snappy, biểu mẫu định giá nhà tự động bằng LightGBM theo thời gian thực.</a:t>
             </a:r>
           </a:p>
         </p:txBody>
@@ -5540,7 +5540,7 @@
               </a:defRPr>
             </a:pPr>
             <a:r>
-              <a:t>SV: Phạm Văn Minh (MSV: 23010350) — Trường Công nghệ Thông tin, Đại học Phenikaa                                                     Slide 15 / 16</a:t>
+              <a:t>Sinh viên: Phạm Văn Minh - Mã sinh viên: 23010350 - Trường Đại học Phenikaa                                                     Slide 15 / 16</a:t>
             </a:r>
           </a:p>
         </p:txBody>
@@ -5614,7 +5614,7 @@
                 </a:solidFill>
                 <a:latin typeface="Arial"/>
               </a:rPr>
-              <a:t>• Hoàn thiện pipeline 6 tầng: </a:t>
+              <a:t>• Hoàn thiện quy trình 6 tầng: </a:t>
             </a:r>
             <a:r>
               <a:rPr sz="1100" b="0">
@@ -5623,7 +5623,7 @@
                 </a:solidFill>
                 <a:latin typeface="Arial"/>
               </a:rPr>
-              <a:t>Tuân thủ chuẩn mực Medallion Lakehouse, xử lý phân tán PySpark.</a:t>
+              <a:t>Tuân thủ chuẩn mực Hồ dữ liệu Medallion, xử lý phân tán PySpark.</a:t>
             </a:r>
           </a:p>
           <a:p>
@@ -5673,7 +5673,7 @@
                 </a:solidFill>
                 <a:latin typeface="Arial"/>
               </a:rPr>
-              <a:t>R² = 0.8537, MdAPE = 20.47%, vượt trội hoàn toàn baseline Ridge.</a:t>
+              <a:t>R² = 0.8537, MdAPE = 20.47%, vượt trội hoàn toàn so với mô hình cơ sở Ridge.</a:t>
             </a:r>
           </a:p>
           <a:p>
@@ -5698,7 +5698,7 @@
                 </a:solidFill>
                 <a:latin typeface="Arial"/>
               </a:rPr>
-              <a:t>10/10 ca Pytest passed, đóng gói batch 1-click Windows và Streamlit App.</a:t>
+              <a:t>10/10 ca kiểm thử đạt yêu cầu, đóng gói kịch bản tự động trên Windows và ứng dụng Web Streamlit.</a:t>
             </a:r>
           </a:p>
         </p:txBody>
@@ -5781,7 +5781,7 @@
                 </a:solidFill>
                 <a:latin typeface="Arial"/>
               </a:rPr>
-              <a:t>Thực nghiệm trên 1 shard (350k dòng) do giới hạn máy trạm cá nhân; mở rộng 3.5M dòng cần cụm Spark Cluster.</a:t>
+              <a:t>Thực nghiệm trên 1 phân mảnh (350k dòng) do giới hạn máy trạm cá nhân; mở rộng 3.5 triệu dòng cần cụm máy chủ Spark phân tán.</a:t>
             </a:r>
           </a:p>
           <a:p>
@@ -5806,7 +5806,7 @@
                 </a:solidFill>
                 <a:latin typeface="Arial"/>
               </a:rPr>
-              <a:t>Asking price phản ánh kỳ vọng người bán, thường cao hơn 5-15% so với giá giao dịch thực tế tại phòng công chứng.</a:t>
+              <a:t>Giá rao bán phản ánh kỳ vọng người bán, thường cao hơn 5-15% so với giá giao dịch thực tế tại phòng công chứng.</a:t>
             </a:r>
           </a:p>
           <a:p>
@@ -5856,7 +5856,7 @@
                 </a:solidFill>
                 <a:latin typeface="Arial"/>
               </a:rPr>
-              <a:t>Mở rộng cụm phân tán Spark trên Cloud, tích hợp Geocoding API và mô hình đồ thị tri thức GNN.</a:t>
+              <a:t>Mở rộng cụm phân tán Spark trên Cloud, tích hợp dịch vụ Geocoding API và mô hình đồ thị tri thức GNN.</a:t>
             </a:r>
           </a:p>
         </p:txBody>
@@ -5972,7 +5972,7 @@
               </a:defRPr>
             </a:pPr>
             <a:r>
-              <a:t>KÍNH MỜI QUÝ THẦY CÔ ĐẶT CÂU HỎI &amp; ĐÓNG GÓP Ý KIẾN (Q &amp; A)</a:t>
+              <a:t>KÍNH MỜI QUÝ THẦY CÔ ĐẶT CÂU HỎI VÀ ĐÓNG GÓP Ý KIẾN</a:t>
             </a:r>
           </a:p>
           <a:p>
@@ -5988,7 +5988,7 @@
               </a:defRPr>
             </a:pPr>
             <a:r>
-              <a:t>Sinh viên thực hiện: Phạm Văn Minh  —  MSV: 23010350</a:t>
+              <a:t>Sinh viên thực hiện: Phạm Văn Minh  —  Mã sinh viên: 23010350</a:t>
             </a:r>
           </a:p>
           <a:p>
@@ -6107,7 +6107,7 @@
               </a:defRPr>
             </a:pPr>
             <a:r>
-              <a:t>SV: Phạm Văn Minh (MSV: 23010350) — Trường Công nghệ Thông tin, Đại học Phenikaa                                                     Slide 2 / 16</a:t>
+              <a:t>Sinh viên: Phạm Văn Minh - Mã sinh viên: 23010350 - Trường Đại học Phenikaa                                                     Slide 2 / 16</a:t>
             </a:r>
           </a:p>
         </p:txBody>
@@ -6188,7 +6188,7 @@
               </a:defRPr>
             </a:pPr>
             <a:r>
-              <a:t>bản ghi trên 10 phân mảnh (shards)</a:t>
+              <a:t>bản ghi trên 10 phân mảnh</a:t>
             </a:r>
           </a:p>
         </p:txBody>
@@ -6269,7 +6269,7 @@
               </a:defRPr>
             </a:pPr>
             <a:r>
-              <a:t>bản ghi thô (Shard 0000 Parquet)</a:t>
+              <a:t>bản ghi thô Shard 0000 Parquet</a:t>
             </a:r>
           </a:p>
         </p:txBody>
@@ -6408,7 +6408,7 @@
               </a:defRPr>
             </a:pPr>
             <a:r>
-              <a:t>4 THÁCH THỨC ĐẶC THÙ CỦA DỮ LIỆU BẤT ĐỘNG SẢN VIỆT NAM &amp; GIẢI PHÁP 6V:</a:t>
+              <a:t>4 THÁCH THỨC ĐẶC THÙ CỦA DỮ LIỆU BẤT ĐỘNG SẢN VIỆT NAM:</a:t>
             </a:r>
           </a:p>
           <a:p>
@@ -6424,7 +6424,7 @@
                 </a:solidFill>
                 <a:latin typeface="Arial"/>
               </a:rPr>
-              <a:t>• Volume (Quy mô cực lớn): </a:t>
+              <a:t>• Quy mô dữ liệu lớn: </a:t>
             </a:r>
             <a:r>
               <a:rPr sz="1200" b="0">
@@ -6433,7 +6433,7 @@
                 </a:solidFill>
                 <a:latin typeface="Arial"/>
               </a:rPr>
-              <a:t>3.5 triệu tin đăng vượt quá khả năng xử lý của pandas in-memory; giải quyết bằng kiến trúc xử lý phân tán Apache PySpark.</a:t>
+              <a:t>3.5 triệu tin đăng vượt quá khả năng xử lý trên bộ nhớ đơn lẻ; giải quyết bằng kiến trúc xử lý phân tán Apache PySpark.</a:t>
             </a:r>
           </a:p>
           <a:p>
@@ -6449,7 +6449,7 @@
                 </a:solidFill>
                 <a:latin typeface="Arial"/>
               </a:rPr>
-              <a:t>• Veracity (Độ tin cậy &amp; Nhiễu loạn): </a:t>
+              <a:t>• Độ tin cậy và xử lý nhiễu loạn: </a:t>
             </a:r>
             <a:r>
               <a:rPr sz="1200" b="0">
@@ -6458,7 +6458,7 @@
                 </a:solidFill>
                 <a:latin typeface="Arial"/>
               </a:rPr>
-              <a:t>Môi giới spam hàng loạt tin trùng lặp; tin rác báo giá ảo 881,020 tỷ đồng, diện tích 24 triệu m²; thiếu chuẩn hóa đơn vị (tỷ, triệu, đ/m², thương lượng).</a:t>
+              <a:t>Môi giới đăng tải hàng loạt tin trùng lặp; tin rác báo giá ảo 881,020 tỷ đồng, diện tích 24 triệu m²; thiếu chuẩn hóa đơn vị (tỷ, triệu, đ/m², thương lượng).</a:t>
             </a:r>
           </a:p>
           <a:p>
@@ -6474,7 +6474,7 @@
                 </a:solidFill>
                 <a:latin typeface="Arial"/>
               </a:rPr>
-              <a:t>• Variety (Dữ liệu phi cấu trúc phức tạp): </a:t>
+              <a:t>• Dữ liệu văn bản phi cấu trúc: </a:t>
             </a:r>
             <a:r>
               <a:rPr sz="1200" b="0">
@@ -6483,7 +6483,7 @@
                 </a:solidFill>
                 <a:latin typeface="Arial"/>
               </a:rPr>
-              <a:t>Yếu tố định giá quan trọng (Sổ đỏ, nhà mặt tiền, ngõ ô tô) ẩn giấu trong văn bản miêu tả; giải quyết bằng bộ trích xuất biểu thức chính quy (Regex NLP).</a:t>
+              <a:t>Yếu tố định giá quan trọng như sổ đỏ, nhà mặt tiền, ngõ ô tô ẩn giấu trong văn bản miêu tả; giải quyết bằng bộ trích xuất biểu thức chính quy tự động.</a:t>
             </a:r>
           </a:p>
           <a:p>
@@ -6499,7 +6499,7 @@
                 </a:solidFill>
                 <a:latin typeface="Arial"/>
               </a:rPr>
-              <a:t>• Velocity &amp; Lineage (Truy vết nguồn gốc): </a:t>
+              <a:t>• Truy vết nguồn gốc và kiểm toán: </a:t>
             </a:r>
             <a:r>
               <a:rPr sz="1200" b="0">
@@ -6508,7 +6508,7 @@
                 </a:solidFill>
                 <a:latin typeface="Arial"/>
               </a:rPr>
-              <a:t>Tin đăng phát sinh liên tục theo thời gian; hệ thống gắn audit metadata (ingested_at, batch_id, source_shard) bảo đảm khả năng tái lập 100%.</a:t>
+              <a:t>Tin đăng phát sinh liên tục theo thời gian; hệ thống gắn siêu dữ liệu kiểm toán gồm thời điểm nạp, mã lô và phân mảnh nguồn.</a:t>
             </a:r>
           </a:p>
           <a:p>
@@ -6524,7 +6524,7 @@
                 </a:solidFill>
                 <a:latin typeface="Arial"/>
               </a:rPr>
-              <a:t>• Value &amp; Valence (Giá trị ứng dụng): </a:t>
+              <a:t>• Giá trị ứng dụng thực tiễn: </a:t>
             </a:r>
             <a:r>
               <a:rPr sz="1200" b="0">
@@ -6533,7 +6533,7 @@
                 </a:solidFill>
                 <a:latin typeface="Arial"/>
               </a:rPr>
-              <a:t>Xây dựng mô hình AI định giá tự động (LightGBM) và bảng điều khiển Streamlit tương tác 4 phân hệ hỗ trợ ra quyết định đầu tư.</a:t>
+              <a:t>Xây dựng mô hình định giá tự động LightGBM và bảng điều khiển Streamlit tương tác 4 phân hệ hỗ trợ ra quyết định đầu tư.</a:t>
             </a:r>
           </a:p>
         </p:txBody>
@@ -6603,7 +6603,7 @@
               </a:defRPr>
             </a:pPr>
             <a:r>
-              <a:t>2. Kiến Trúc Hồ Dữ Liệu Medallion Lakehouse 6 Tầng</a:t>
+              <a:t>2. Kiến Trúc Hồ Dữ Liệu Medallion 6 Tầng</a:t>
             </a:r>
           </a:p>
         </p:txBody>
@@ -6639,7 +6639,7 @@
               </a:defRPr>
             </a:pPr>
             <a:r>
-              <a:t>SV: Phạm Văn Minh (MSV: 23010350) — Trường Công nghệ Thông tin, Đại học Phenikaa                                                     Slide 3 / 16</a:t>
+              <a:t>Sinh viên: Phạm Văn Minh - Mã sinh viên: 23010350 - Trường Đại học Phenikaa                                                     Slide 3 / 16</a:t>
             </a:r>
           </a:p>
         </p:txBody>
@@ -6737,7 +6737,7 @@
                 </a:solidFill>
                 <a:latin typeface="Arial"/>
               </a:rPr>
-              <a:t>• 1. Ingestion: </a:t>
+              <a:t>• 1. Thu nạp thô: </a:t>
             </a:r>
             <a:r>
               <a:rPr sz="1100" b="0">
@@ -6746,7 +6746,7 @@
                 </a:solidFill>
                 <a:latin typeface="Arial"/>
               </a:rPr>
-              <a:t>Nạp bất đồng bộ từ Hugging Face Hub (Polars/Arrow), gán mã lô batch_id &amp; timestamp.</a:t>
+              <a:t>Nạp bất đồng bộ từ Hugging Face qua Polars và Arrow, gắn mã định danh lô và thời điểm nạp.</a:t>
             </a:r>
           </a:p>
           <a:p>
@@ -6762,7 +6762,7 @@
                 </a:solidFill>
                 <a:latin typeface="Arial"/>
               </a:rPr>
-              <a:t>• 2. Bronze Zone: </a:t>
+              <a:t>• 2. Tầng Đồng: </a:t>
             </a:r>
             <a:r>
               <a:rPr sz="1100" b="0">
@@ -6771,7 +6771,7 @@
                 </a:solidFill>
                 <a:latin typeface="Arial"/>
               </a:rPr>
-              <a:t>Lưu trữ nguyên trạng bất biến (Immutable Data) định dạng Parquet Snappy (350,075 dòng, 153.9 MB).</a:t>
+              <a:t>Lưu trữ nguyên trạng bất biến định dạng Parquet Snappy (350,075 dòng, 153.9 MB).</a:t>
             </a:r>
           </a:p>
           <a:p>
@@ -6787,7 +6787,7 @@
                 </a:solidFill>
                 <a:latin typeface="Arial"/>
               </a:rPr>
-              <a:t>• 3. Silver Zone: </a:t>
+              <a:t>• 3. Tầng Bạc: </a:t>
             </a:r>
             <a:r>
               <a:rPr sz="1100" b="0">
@@ -6796,7 +6796,7 @@
                 </a:solidFill>
                 <a:latin typeface="Arial"/>
               </a:rPr>
-              <a:t>Làm sạch PySpark, khử trùng lặp đa thuộc tính, chuẩn hóa kiểu dữ liệu số (307,457 dòng, 130.0 MB).</a:t>
+              <a:t>Làm sạch bằng PySpark, khử trùng lặp đa thuộc tính, chuẩn hóa kiểu dữ liệu số (307,457 dòng, 130.0 MB).</a:t>
             </a:r>
           </a:p>
           <a:p>
@@ -6812,7 +6812,7 @@
                 </a:solidFill>
                 <a:latin typeface="Arial"/>
               </a:rPr>
-              <a:t>• 4. Gold Zone: </a:t>
+              <a:t>• 4. Tầng Vàng: </a:t>
             </a:r>
             <a:r>
               <a:rPr sz="1100" b="0">
@@ -6821,7 +6821,7 @@
                 </a:solidFill>
                 <a:latin typeface="Arial"/>
               </a:rPr>
-              <a:t>Lọc ngoại lệ IQR, trích xuất đặc trưng NLP, log-transform (300,295 dòng, 128.2 MB).</a:t>
+              <a:t>Lọc ngoại lệ, trích xuất đặc trưng văn bản, biến đổi chuẩn hóa logarit (300,295 dòng, 128.2 MB).</a:t>
             </a:r>
           </a:p>
           <a:p>
@@ -6837,7 +6837,7 @@
                 </a:solidFill>
                 <a:latin typeface="Arial"/>
               </a:rPr>
-              <a:t>• 5. Serving DB: </a:t>
+              <a:t>• 5. CSDL Phục vụ: </a:t>
             </a:r>
             <a:r>
               <a:rPr sz="1100" b="0">
@@ -6846,7 +6846,7 @@
                 </a:solidFill>
                 <a:latin typeface="Arial"/>
               </a:rPr>
-              <a:t>PostgreSQL / SQLite Indexing, đánh 4 chỉ mục B-Tree, nạp chunk 10k, dung lượng chỉ 17.4 MB.</a:t>
+              <a:t>PostgreSQL và SQLite, đánh 4 chỉ mục B-Tree, nạp theo khối 10,000 dòng, dung lượng chỉ 17.4 MB.</a:t>
             </a:r>
           </a:p>
           <a:p>
@@ -6862,7 +6862,7 @@
                 </a:solidFill>
                 <a:latin typeface="Arial"/>
               </a:rPr>
-              <a:t>• 6. Serving ML/UI: </a:t>
+              <a:t>• 6. Giao diện &amp; ML: </a:t>
             </a:r>
             <a:r>
               <a:rPr sz="1100" b="0">
@@ -6871,7 +6871,7 @@
                 </a:solidFill>
                 <a:latin typeface="Arial"/>
               </a:rPr>
-              <a:t>Mô hình LightGBM định giá trực tuyến &amp; Dashboard Streamlit 4 Tab tương tác.</a:t>
+              <a:t>Mô hình LightGBM định giá trực tuyến và Bảng điều khiển Streamlit 4 Tab tương tác.</a:t>
             </a:r>
           </a:p>
         </p:txBody>
@@ -6977,7 +6977,7 @@
               </a:defRPr>
             </a:pPr>
             <a:r>
-              <a:t>SV: Phạm Văn Minh (MSV: 23010350) — Trường Công nghệ Thông tin, Đại học Phenikaa                                                     Slide 4 / 16</a:t>
+              <a:t>Sinh viên: Phạm Văn Minh - Mã sinh viên: 23010350 - Trường Đại học Phenikaa                                                     Slide 4 / 16</a:t>
             </a:r>
           </a:p>
         </p:txBody>
@@ -7084,7 +7084,7 @@
                 </a:solidFill>
                 <a:latin typeface="Arial"/>
               </a:rPr>
-              <a:t>K_dedup = Hash(lower(name) || province || district || ward || price_str || area)</a:t>
+              <a:t>K_khử_trùng = Băm(chữ_thường(tiêu_đề) || tỉnh || huyện || xã || chuỗi_giá || diện_tích)</a:t>
             </a:r>
           </a:p>
           <a:p>
@@ -7150,7 +7150,7 @@
                 </a:solidFill>
                 <a:latin typeface="Arial"/>
               </a:rPr>
-              <a:t>• Tỷ lệ giữ lại Tầng Bạc (Silver): </a:t>
+              <a:t>• Tỷ lệ giữ lại Tầng Bạc: </a:t>
             </a:r>
             <a:r>
               <a:rPr sz="1100" b="0">
@@ -7159,7 +7159,7 @@
                 </a:solidFill>
                 <a:latin typeface="Arial"/>
               </a:rPr>
-              <a:t>307,457 bản ghi sạch (giữ lại 87.83% so với Tầng Đồng Bronze).</a:t>
+              <a:t>307,457 bản ghi sạch (đạt 87.83% so với Tầng Đồng ban đầu).</a:t>
             </a:r>
           </a:p>
           <a:p>
@@ -7175,7 +7175,7 @@
                 </a:solidFill>
                 <a:latin typeface="Arial"/>
               </a:rPr>
-              <a:t>• Tỷ lệ toàn trình (Overall): </a:t>
+              <a:t>• Tỷ lệ toàn trình: </a:t>
             </a:r>
             <a:r>
               <a:rPr sz="1100" b="0">
@@ -7184,7 +7184,7 @@
                 </a:solidFill>
                 <a:latin typeface="Arial"/>
               </a:rPr>
-              <a:t>Toàn bộ pipeline giữ lại 85.78% dữ liệu chuẩn mực, vượt xa tiêu chí nghiệm thu &gt;= 80%.</a:t>
+              <a:t>Toàn bộ pipeline giữ lại 85.78% dữ liệu chuẩn mực, vượt xa tiêu chuẩn nghiệm thu 80%.</a:t>
             </a:r>
           </a:p>
         </p:txBody>
@@ -7290,7 +7290,7 @@
               </a:defRPr>
             </a:pPr>
             <a:r>
-              <a:t>SV: Phạm Văn Minh (MSV: 23010350) — Trường Công nghệ Thông tin, Đại học Phenikaa                                                     Slide 5 / 16</a:t>
+              <a:t>Sinh viên: Phạm Văn Minh - Mã sinh viên: 23010350 - Trường Đại học Phenikaa                                                     Slide 5 / 16</a:t>
             </a:r>
           </a:p>
         </p:txBody>
@@ -7388,7 +7388,7 @@
                 </a:solidFill>
                 <a:latin typeface="Arial"/>
               </a:rPr>
-              <a:t>• Nhóm sạch (&lt; 5% null): </a:t>
+              <a:t>• Nhóm sạch (&lt; 5% khuyết): </a:t>
             </a:r>
             <a:r>
               <a:rPr sz="1100" b="0">
@@ -7397,7 +7397,7 @@
                 </a:solidFill>
                 <a:latin typeface="Arial"/>
               </a:rPr>
-              <a:t>name (0%), description (0%), province (0%), district (1.75%), price (0%), area (0%). Giữ nguyên vẹn, điền 'Không rõ' cho quận huyện thiếu.</a:t>
+              <a:t>Tiêu đề (0%), mô tả (0%), tỉnh thành (0%), quận huyện (1.75%), giá bán (0%), diện tích (0%). Giữ nguyên vẹn, điền 'Không rõ' cho quận huyện thiếu.</a:t>
             </a:r>
           </a:p>
           <a:p>
@@ -7422,7 +7422,7 @@
                 </a:solidFill>
                 <a:latin typeface="Arial"/>
               </a:rPr>
-              <a:t>ward (14.4%), street (40.4%), bedroom (24.8%), direction (46.8%). Điền 'Không rõ' cho phân loại và Median theo quận cho số phòng ngủ.</a:t>
+              <a:t>Phường xã (14.4%), tên đường (40.4%), số phòng ngủ (24.8%), hướng nhà (46.8%). Điền 'Không rõ' cho phân loại và giá trị trung vị theo quận cho số phòng ngủ.</a:t>
             </a:r>
           </a:p>
           <a:p>
@@ -7447,7 +7447,7 @@
                 </a:solidFill>
                 <a:latin typeface="Arial"/>
               </a:rPr>
-              <a:t>project_name (86.1%), frontage_width (64.2%), road_width (61.5%).</a:t>
+              <a:t>Tên dự án (86.1%), mặt tiền (64.2%), độ rộng đường (61.5%).</a:t>
             </a:r>
           </a:p>
           <a:p>
@@ -7472,7 +7472,7 @@
                 </a:solidFill>
                 <a:latin typeface="Arial"/>
               </a:rPr>
-              <a:t>TUYỆT ĐỐI KHÔNG XÓA CỘT khuyết cao vì khi có dữ liệu (ví dụ nhà mặt phố), giá trị kinh tế tăng vọt. Áp dụng Imputer chuyên biệt &amp; nhị phân hóa cờ NLP.</a:t>
+              <a:t>TUYỆT ĐỐI KHÔNG XÓA CỘT khuyết cao vì khi có dữ liệu (ví dụ nhà mặt phố), giá trị kinh tế tăng vọt. Áp dụng kỹ thuật điền khuyết riêng biệt và nhị phân hóa cờ đặc trưng.</a:t>
             </a:r>
           </a:p>
         </p:txBody>
@@ -7542,7 +7542,7 @@
               </a:defRPr>
             </a:pPr>
             <a:r>
-              <a:t>5. Thuật Toán Lọc Ngoại Lệ Thống Kê (Domain + IQR)</a:t>
+              <a:t>5. Thuật Toán Lọc Ngoại Lệ Thống Kê Kháng Nhiễu</a:t>
             </a:r>
           </a:p>
         </p:txBody>
@@ -7578,7 +7578,7 @@
               </a:defRPr>
             </a:pPr>
             <a:r>
-              <a:t>SV: Phạm Văn Minh (MSV: 23010350) — Trường Công nghệ Thông tin, Đại học Phenikaa                                                     Slide 6 / 16</a:t>
+              <a:t>Sinh viên: Phạm Văn Minh - Mã sinh viên: 23010350 - Trường Đại học Phenikaa                                                     Slide 6 / 16</a:t>
             </a:r>
           </a:p>
         </p:txBody>
@@ -7685,7 +7685,7 @@
                 </a:solidFill>
                 <a:latin typeface="Arial"/>
               </a:rPr>
-              <a:t>Kết hợp biên nghiệp vụ [0.1 - 500 tỷ, 10 - 5000 m²] với phân vị IQR trên log-scale.</a:t>
+              <a:t>Kết hợp biên nghiệp vụ [0.1 - 500 tỷ, 10 - 5000 m²] với phân vị khoảng liên tứ phân vị trên thang logarit.</a:t>
             </a:r>
           </a:p>
           <a:p>
@@ -7701,7 +7701,7 @@
                 </a:solidFill>
                 <a:latin typeface="Arial"/>
               </a:rPr>
-              <a:t>• Độ lệch chuẩn Giá (Std): </a:t>
+              <a:t>• Độ lệch chuẩn Giá bán: </a:t>
             </a:r>
             <a:r>
               <a:rPr sz="1050" b="0">
@@ -7735,7 +7735,7 @@
                 </a:solidFill>
                 <a:latin typeface="Arial"/>
               </a:rPr>
-              <a:t>7.2 Tỷ (Silver) -&gt; 7.3 Tỷ (Gold). Không làm méo mó bản chất thị trường!</a:t>
+              <a:t>7.2 Tỷ ở Tầng Bạc -&gt; 7.3 Tỷ ở Tầng Vàng. Không làm méo mó bản chất thị trường!</a:t>
             </a:r>
           </a:p>
           <a:p>
@@ -7751,7 +7751,7 @@
                 </a:solidFill>
                 <a:latin typeface="Arial"/>
               </a:rPr>
-              <a:t>• Độ lệch chuẩn Diện tích (Std): </a:t>
+              <a:t>• Độ lệch chuẩn Diện tích: </a:t>
             </a:r>
             <a:r>
               <a:rPr sz="1050" b="0">
@@ -7760,7 +7760,7 @@
                 </a:solidFill>
                 <a:latin typeface="Arial"/>
               </a:rPr>
-              <a:t>Từ 51,332 m² GIẢM 208 LẦN còn 246.5 m² (Triệt tiêu diện tích ảo 24M m²).</a:t>
+              <a:t>Từ 51,332 m² GIẢM 208 LẦN còn 246.5 m² (Triệt tiêu diện tích ảo 24 triệu m²).</a:t>
             </a:r>
           </a:p>
           <a:p>
@@ -7801,7 +7801,7 @@
                 </a:solidFill>
                 <a:latin typeface="Arial"/>
               </a:rPr>
-              <a:t>• Độ lệch chuẩn Đơn giá/m²: </a:t>
+              <a:t>• Độ lệch chuẩn Đơn giá: </a:t>
             </a:r>
             <a:r>
               <a:rPr sz="1050" b="0">
@@ -7880,7 +7880,7 @@
               </a:defRPr>
             </a:pPr>
             <a:r>
-              <a:t>6. Toàn Cảnh Thị Trường Bất Động Sản (Big Data EDA)</a:t>
+              <a:t>6. Toàn Cảnh Thị Trường Bất Động Sản</a:t>
             </a:r>
           </a:p>
         </p:txBody>
@@ -7916,7 +7916,7 @@
               </a:defRPr>
             </a:pPr>
             <a:r>
-              <a:t>SV: Phạm Văn Minh (MSV: 23010350) — Trường Công nghệ Thông tin, Đại học Phenikaa                                                     Slide 7 / 16</a:t>
+              <a:t>Sinh viên: Phạm Văn Minh - Mã sinh viên: 23010350 - Trường Đại học Phenikaa                                                     Slide 7 / 16</a:t>
             </a:r>
           </a:p>
         </p:txBody>
@@ -7998,7 +7998,7 @@
               </a:defRPr>
             </a:pPr>
             <a:r>
-              <a:t>INSIGHT PHÂN BỐ THỊ TRƯỜNG:</a:t>
+              <a:t>PHÂN TÍCH KHÁM PHÁ THỊ TRƯỜNG:</a:t>
             </a:r>
           </a:p>
           <a:p>
@@ -8073,7 +8073,7 @@
                 </a:solidFill>
                 <a:latin typeface="Arial"/>
               </a:rPr>
-              <a:t>Đà Nẵng median 7.57 Tỷ (thị trường ven biển); Bình Dương median 2.91 Tỷ (nhà ở công nghiệp/chuyên gia).</a:t>
+              <a:t>Đà Nẵng trung vị 7.57 Tỷ (thị trường ven biển); Bình Dương trung vị 2.91 Tỷ (nhà ở công nghiệp/chuyên gia).</a:t>
             </a:r>
           </a:p>
           <a:p>
@@ -8168,7 +8168,7 @@
               </a:defRPr>
             </a:pPr>
             <a:r>
-              <a:t>7. Kỹ Thuật Đặc Trưng Văn Bản NLP &amp; Chuẩn Hóa Logarit</a:t>
+              <a:t>7. Kỹ Thuật Đặc Trưng Văn Bản &amp; Chuẩn Hóa Logarit</a:t>
             </a:r>
           </a:p>
         </p:txBody>
@@ -8204,7 +8204,7 @@
               </a:defRPr>
             </a:pPr>
             <a:r>
-              <a:t>SV: Phạm Văn Minh (MSV: 23010350) — Trường Công nghệ Thông tin, Đại học Phenikaa                                                     Slide 8 / 16</a:t>
+              <a:t>Sinh viên: Phạm Văn Minh - Mã sinh viên: 23010350 - Trường Đại học Phenikaa                                                     Slide 8 / 16</a:t>
             </a:r>
           </a:p>
         </p:txBody>
@@ -8286,7 +8286,7 @@
               </a:defRPr>
             </a:pPr>
             <a:r>
-              <a:t>TRÍCH XUẤT NLP &amp; LOG-SCALE:</a:t>
+              <a:t>TRÍCH XUẤT ĐẶC TRƯNG &amp; CHUẨN HÓA:</a:t>
             </a:r>
           </a:p>
           <a:p>
@@ -8302,7 +8302,7 @@
                 </a:solidFill>
                 <a:latin typeface="Arial"/>
               </a:rPr>
-              <a:t>• Cờ pháp lý (has_so_do): </a:t>
+              <a:t>• Cờ pháp lý sổ đỏ/hồng: </a:t>
             </a:r>
             <a:r>
               <a:rPr sz="1100" b="0">
@@ -8327,7 +8327,7 @@
                 </a:solidFill>
                 <a:latin typeface="Arial"/>
               </a:rPr>
-              <a:t>• Cờ vị trí (is_frontage, is_alley): </a:t>
+              <a:t>• Cờ vị trí mặt phố và ngõ hẻm: </a:t>
             </a:r>
             <a:r>
               <a:rPr sz="1100" b="0">
@@ -8336,7 +8336,7 @@
                 </a:solidFill>
                 <a:latin typeface="Arial"/>
               </a:rPr>
-              <a:t>Nhận diện 'mặt phố', 'kinh doanh' vs 'ngõ hẻm', 'ba gác'. Mặt phố có đơn giá gấp 2-3 lần nhà ngõ.</a:t>
+              <a:t>Nhận diện 'mặt phố', 'kinh doanh' so với 'ngõ hẻm', 'ba gác'. Mặt phố có đơn giá gấp 2-3 lần nhà ngõ.</a:t>
             </a:r>
           </a:p>
           <a:p>
@@ -8352,7 +8352,7 @@
                 </a:solidFill>
                 <a:latin typeface="Arial"/>
               </a:rPr>
-              <a:t>• Cờ tiện nghi (has_furniture, has_car_access): </a:t>
+              <a:t>• Cờ tiện nghi nội thất và ô tô: </a:t>
             </a:r>
             <a:r>
               <a:rPr sz="1100" b="0">
@@ -8377,7 +8377,7 @@
                 </a:solidFill>
                 <a:latin typeface="Arial"/>
               </a:rPr>
-              <a:t>• Biến đổi log1p(price) &amp; log1p(area): </a:t>
+              <a:t>• Biến đổi logarit tự nhiên: </a:t>
             </a:r>
             <a:r>
               <a:rPr sz="1100" b="0">
@@ -8386,7 +8386,7 @@
                 </a:solidFill>
                 <a:latin typeface="Arial"/>
               </a:rPr>
-              <a:t>Kéo độ lệch Skewness từ 6.70 xuống 0.24 (gần chuẩn Gauss), giúp hàm mất mát MSE hội tụ tối ưu.</a:t>
+              <a:t>Kéo hệ số bất đối xứng từ 6.70 xuống 0.24 (gần chuẩn đối xứng), giúp hàm mục tiêu hội tụ tối ưu.</a:t>
             </a:r>
           </a:p>
         </p:txBody>
@@ -8456,7 +8456,7 @@
               </a:defRPr>
             </a:pPr>
             <a:r>
-              <a:t>8. Giao Thức Phân Chia 3 Chiều Chống Rò Rỉ Dữ Liệu</a:t>
+              <a:t>8. Giao Thức Phân Chia Ba Tập Dữ Liệu Chống Rò Rỉ</a:t>
             </a:r>
           </a:p>
         </p:txBody>
@@ -8492,7 +8492,7 @@
               </a:defRPr>
             </a:pPr>
             <a:r>
-              <a:t>SV: Phạm Văn Minh (MSV: 23010350) — Trường Công nghệ Thông tin, Đại học Phenikaa                                                     Slide 9 / 16</a:t>
+              <a:t>Sinh viên: Phạm Văn Minh - Mã sinh viên: 23010350 - Trường Đại học Phenikaa                                                     Slide 9 / 16</a:t>
             </a:r>
           </a:p>
         </p:txBody>
@@ -8550,7 +8550,7 @@
               </a:defRPr>
             </a:pPr>
             <a:r>
-              <a:t>TẬP HUẤN LUYỆN (TRAIN SET)</a:t>
+              <a:t>TẬP HUẤN LUYỆN</a:t>
             </a:r>
           </a:p>
           <a:p>
@@ -8592,7 +8592,7 @@
               </a:defRPr>
             </a:pPr>
             <a:r>
-              <a:t>Toàn bộ Target Encoding, Imputer, Scaler CHỈ ĐƯỢC FIT trên tập dữ liệu này. Tuyệt đối không nhìn trước dữ liệu tương lai.</a:t>
+              <a:t>Toàn bộ tiền xử lý phân loại, điền khuyết, chuẩn hóa CHỈ ĐƯỢC HỌC trên tập dữ liệu này. Tuyệt đối không nhìn trước dữ liệu kiểm thử.</a:t>
             </a:r>
           </a:p>
         </p:txBody>
@@ -8650,7 +8650,7 @@
               </a:defRPr>
             </a:pPr>
             <a:r>
-              <a:t>TẬP KIỂM ĐỊNH (VALIDATION SET)</a:t>
+              <a:t>TẬP KIỂM ĐỊNH</a:t>
             </a:r>
           </a:p>
           <a:p>
@@ -8692,7 +8692,7 @@
               </a:defRPr>
             </a:pPr>
             <a:r>
-              <a:t>Sử dụng độc quyền để điều chỉnh siêu tham số (Hyperparameter Tuning) và cơ chế Early Stopping chống Overfitting.</a:t>
+              <a:t>Sử dụng độc quyền để điều chỉnh siêu tham số và kích hoạt cơ chế dừng sớm chống quá khớp.</a:t>
             </a:r>
           </a:p>
         </p:txBody>
@@ -8750,7 +8750,7 @@
               </a:defRPr>
             </a:pPr>
             <a:r>
-              <a:t>TẬP KIỂM THỬ ĐỘC LẬP (TEST SET)</a:t>
+              <a:t>TẬP KIỂM THỬ ĐỘC LẬP</a:t>
             </a:r>
           </a:p>
           <a:p>

</xml_diff>